<commit_message>
Fix pale graphs on slides 5-6 by switching background to white
LIGHT_GREY (#F0F2F5) was too close to the matplotlib figure backgrounds
(#FFFFFF), causing charts to blend into a low-contrast wash. Changed
slides 5 and 6 to pure white so figure colors render with full contrast.

Co-Authored-By: Claude Sonnet 4.6 <noreply@anthropic.com>
</commit_message>
<xml_diff>
--- a/presentation.pptx
+++ b/presentation.pptx
@@ -5200,7 +5200,7 @@
     <p:bg>
       <p:bgPr>
         <a:solidFill>
-          <a:srgbClr val="F0F2F5"/>
+          <a:srgbClr val="FFFFFF"/>
         </a:solidFill>
         <a:effectLst/>
       </p:bgPr>
@@ -5543,7 +5543,7 @@
     <p:bg>
       <p:bgPr>
         <a:solidFill>
-          <a:srgbClr val="F0F2F5"/>
+          <a:srgbClr val="FFFFFF"/>
         </a:solidFill>
         <a:effectLst/>
       </p:bgPr>

</xml_diff>